<commit_message>
Close the gap a control word's terminating space leaves on a slide
Slides showed "Δ G", "Xᵀ X" and "Σ v = λ v". The space in $\Delta G$ is
there only to tell TeX where the control word ends; TeX itself sets those
closed up, and the Unicode conversion was printing it.

Tightened after conversion rather than per command, so the distinction
that matters survives: a letter-like symbol closes up against what
follows, a relation or binary operator keeps its spacing. α = 0.1 and
8.9 × 10⁻¹⁶ are unchanged; \pm closes up only in unary position.

Also records this review round's deck pass in LESSON_REVIEW, and commits
that document's built PDF alongside the other Course/ documents.

Co-Authored-By: Claude Opus 5 <noreply@anthropic.com>
Claude-Session: https://claude.ai/code/session_01RUgbrkGymrGY6d6KXvKkff
</commit_message>
<xml_diff>
--- a/Lessons/07_trees_and_ensembles/Slides/trees_and_ensembles_slides.pptx
+++ b/Lessons/07_trees_and_ensembles/Slides/trees_and_ensembles_slides.pptx
@@ -802,7 +802,7 @@
             </a:pPr>
             <a:r>
               <a:rPr/>
-              <a:t>mL and mR are the sizes of the two children, mP = mL + mR. Read it as: what the parent’s impurity was, minus what is left after the split, weighted by how the group was divided. The tree keeps whichever candidate split makes Δ G largest.</a:t>
+              <a:t>mL and mR are the sizes of the two children, mP = mL + mR. Read it as: what the parent’s impurity was, minus what is left after the split, weighted by how the group was divided. The tree keeps whichever candidate split makes ΔG largest.</a:t>
             </a:r>
           </a:p>
           <a:p>
@@ -912,7 +912,7 @@
             </a:pPr>
             <a:r>
               <a:rPr/>
-              <a:t>The last bullet is the one to slow down on. A feature that only helps in combination with a second split further down the tree can be - and in this dataset’s two interior islands, is - invisible to a shallow search, because Δ G is never evaluated for two splits together.</a:t>
+              <a:t>The last bullet is the one to slow down on. A feature that only helps in combination with a second split further down the tree can be - and in this dataset’s two interior islands, is - invisible to a shallow search, because ΔG is never evaluated for two splits together.</a:t>
             </a:r>
           </a:p>
           <a:p>
@@ -9609,7 +9609,7 @@
             </a:r>
             <a:r>
               <a:rPr/>
-              <a:t>: Δ G is judged one split at a time, never jointly</a:t>
+              <a:t>: ΔG is judged one split at a time, never jointly</a:t>
             </a:r>
           </a:p>
         </p:txBody>
@@ -10918,7 +10918,7 @@
             </a:r>
             <a:r>
               <a:rPr/>
-              <a:t>: always expanding whichever leaf offers the largest Δ G</a:t>
+              <a:t>: always expanding whichever leaf offers the largest ΔG</a:t>
             </a:r>
           </a:p>
           <a:p>

</xml_diff>